<commit_message>
T2 sustentación: imágenes finales (Nano Banana) y diapositiva 14 sin captura del focus
Co-Authored-By: Claude Fable 5.1 <noreply@anthropic.com>
Claude-Session: https://claude.ai/code/session_01Kfbf7cfV7pXUcNjjyaPCzV
</commit_message>
<xml_diff>
--- a/04-reformulacion/T2/T2_Sustentacion-AndiBite.pptx
+++ b/04-reformulacion/T2/T2_Sustentacion-AndiBite.pptx
@@ -138,14 +138,14 @@
   <p:extLst>
     <p:ext uri="{521415D9-36F7-43E2-AB2F-B90AF26B5E84}">
       <p14:sectionLst xmlns:p14="http://schemas.microsoft.com/office/powerpoint/2010/main">
-        <p14:section name="Apertura" id="{0cfa4d14-20e3-a5dc-c846-5fc4cc7a3dc9}">
+        <p14:section name="Apertura" id="{1d01bb8c-1517-6e01-86a0-2c7b7c230a5a}">
           <p14:sldIdLst>
             <p14:sldId id="256"/>
             <p14:sldId id="257"/>
             <p14:sldId id="258"/>
           </p14:sldIdLst>
         </p14:section>
-        <p14:section name="1 · Canvas" id="{d1e4386a-8932-642c-306c-b9f01c1dabc3}">
+        <p14:section name="1 · Canvas" id="{b0a3ee50-1064-2e50-76cd-e3d416238b31}">
           <p14:sldIdLst>
             <p14:sldId id="259"/>
             <p14:sldId id="260"/>
@@ -153,7 +153,7 @@
             <p14:sldId id="262"/>
           </p14:sldIdLst>
         </p14:section>
-        <p14:section name="2 · Digital" id="{b297da24-fb1d-f41b-f191-ffc96f7fb8b7}">
+        <p14:section name="2 · Digital" id="{0952b926-9259-55e5-b4cc-e1ac1dadbcb2}">
           <p14:sldIdLst>
             <p14:sldId id="263"/>
             <p14:sldId id="264"/>
@@ -162,7 +162,7 @@
             <p14:sldId id="267"/>
           </p14:sldIdLst>
         </p14:section>
-        <p14:section name="3 · Investigación" id="{24f13dcb-4144-cf6d-7866-6e8a9e1daf55}">
+        <p14:section name="3 · Investigación" id="{12ca1345-b91b-62f0-7640-31c714641aec}">
           <p14:sldIdLst>
             <p14:sldId id="268"/>
             <p14:sldId id="269"/>
@@ -175,7 +175,7 @@
             <p14:sldId id="276"/>
           </p14:sldIdLst>
         </p14:section>
-        <p14:section name="4 · Marketing" id="{aeb945b2-10aa-bc6e-5c03-3a936ec076ec}">
+        <p14:section name="4 · Marketing" id="{e2a5475f-8b37-c44f-9509-c7fbd58d8fd5}">
           <p14:sldIdLst>
             <p14:sldId id="277"/>
             <p14:sldId id="278"/>
@@ -185,12 +185,12 @@
             <p14:sldId id="282"/>
           </p14:sldIdLst>
         </p14:section>
-        <p14:section name="Cierre" id="{a91c3bb3-cfdb-c410-5ae8-2e4def960611}">
+        <p14:section name="Cierre" id="{ce117d39-60fd-ef5d-80f4-ee869aa76818}">
           <p14:sldIdLst>
             <p14:sldId id="283"/>
           </p14:sldIdLst>
         </p14:section>
-        <p14:section name="Anexos" id="{fd149300-a88a-616b-0c51-44a7836968c4}">
+        <p14:section name="Anexos" id="{c1aed249-a836-f669-568b-b42f2ea28f25}">
           <p14:sldIdLst>
             <p14:sldId id="284"/>
             <p14:sldId id="285"/>
@@ -7464,17 +7464,67 @@
         </p:blipFill>
         <p:spPr>
           <a:xfrm>
-            <a:off x="5852160" y="1466251"/>
-            <a:ext cx="2798064" cy="1749226"/>
+            <a:off x="5852160" y="1463040"/>
+            <a:ext cx="3364154" cy="2103120"/>
           </a:xfrm>
           <a:prstGeom prst="rect">
             <a:avLst/>
           </a:prstGeom>
         </p:spPr>
       </p:pic>
+      <p:sp>
+        <p:nvSpPr>
+          <p:cNvPr id="13" name="Text 10"/>
+          <p:cNvSpPr txBox="1"/>
+          <p:nvPr/>
+        </p:nvSpPr>
+        <p:spPr>
+          <a:xfrm>
+            <a:off x="9464040" y="1463040"/>
+            <a:ext cx="2194560" cy="2103120"/>
+          </a:xfrm>
+          <a:prstGeom prst="rect">
+            <a:avLst/>
+          </a:prstGeom>
+          <a:noFill/>
+          <a:ln/>
+        </p:spPr>
+        <p:txBody>
+          <a:bodyPr wrap="square" lIns="0" tIns="0" rIns="0" bIns="0" rtlCol="0" anchor="ctr"/>
+          <a:lstStyle/>
+          <a:p>
+            <a:pPr indent="0" marL="0">
+              <a:buNone/>
+            </a:pPr>
+            <a:r>
+              <a:rPr lang="en-US" sz="1600" b="1" dirty="0">
+                <a:solidFill>
+                  <a:srgbClr val="6B3A2A"/>
+                </a:solidFill>
+              </a:rPr>
+              <a:t>Entrevista en casa</a:t>
+            </a:r>
+            <a:endParaRPr lang="en-US" sz="1600" dirty="0"/>
+          </a:p>
+          <a:p>
+            <a:pPr indent="0" marL="0">
+              <a:buNone/>
+            </a:pPr>
+            <a:r>
+              <a:rPr lang="en-US" sz="1600" dirty="0">
+                <a:solidFill>
+                  <a:srgbClr val="6B3A2A"/>
+                </a:solidFill>
+              </a:rPr>
+              <a:t>de la familia, con la mamá y la hija presentes</a:t>
+            </a:r>
+            <a:endParaRPr lang="en-US" sz="1600" dirty="0"/>
+          </a:p>
+        </p:txBody>
+      </p:sp>
       <p:pic>
         <p:nvPicPr>
-          <p:cNvPr id="13" name="Image 1" descr="img/deck/entrevista_2.jpg">    </p:cNvPr>
+          <p:cNvPr id="14" name="Image 1" descr="img/deck/entrevista_2.jpg">    </p:cNvPr>
           <p:cNvPicPr>
             <a:picLocks noChangeAspect="1"/>
           </p:cNvPicPr>
@@ -7488,8 +7538,8 @@
         </p:blipFill>
         <p:spPr>
           <a:xfrm>
-            <a:off x="8842248" y="1466035"/>
-            <a:ext cx="2798064" cy="1749658"/>
+            <a:off x="5852160" y="3703320"/>
+            <a:ext cx="3363323" cy="2103120"/>
           </a:xfrm>
           <a:prstGeom prst="rect">
             <a:avLst/>
@@ -7498,14 +7548,14 @@
       </p:pic>
       <p:sp>
         <p:nvSpPr>
-          <p:cNvPr id="14" name="Text 10"/>
+          <p:cNvPr id="15" name="Text 11"/>
           <p:cNvSpPr txBox="1"/>
           <p:nvPr/>
         </p:nvSpPr>
         <p:spPr>
           <a:xfrm>
-            <a:off x="5852160" y="3246120"/>
-            <a:ext cx="2798064" cy="274320"/>
+            <a:off x="9464040" y="3703320"/>
+            <a:ext cx="2194560" cy="2103120"/>
           </a:xfrm>
           <a:prstGeom prst="rect">
             <a:avLst/>
@@ -7514,164 +7564,41 @@
           <a:ln/>
         </p:spPr>
         <p:txBody>
-          <a:bodyPr wrap="square" lIns="0" tIns="0" rIns="0" bIns="0" rtlCol="0" anchor="t"/>
-          <a:lstStyle/>
-          <a:p>
-            <a:pPr algn="ctr" indent="0" marL="0">
-              <a:buNone/>
-            </a:pPr>
-            <a:r>
-              <a:rPr lang="en-US" sz="1200" dirty="0">
+          <a:bodyPr wrap="square" lIns="0" tIns="0" rIns="0" bIns="0" rtlCol="0" anchor="ctr"/>
+          <a:lstStyle/>
+          <a:p>
+            <a:pPr indent="0" marL="0">
+              <a:buNone/>
+            </a:pPr>
+            <a:r>
+              <a:rPr lang="en-US" sz="1600" b="1" dirty="0">
                 <a:solidFill>
                   <a:srgbClr val="6B3A2A"/>
                 </a:solidFill>
               </a:rPr>
-              <a:t>Entrevista en casa</a:t>
-            </a:r>
-            <a:endParaRPr lang="en-US" sz="1200" dirty="0"/>
-          </a:p>
-        </p:txBody>
-      </p:sp>
-      <p:sp>
-        <p:nvSpPr>
-          <p:cNvPr id="15" name="Text 11"/>
-          <p:cNvSpPr txBox="1"/>
-          <p:nvPr/>
-        </p:nvSpPr>
-        <p:spPr>
-          <a:xfrm>
-            <a:off x="8842248" y="3246120"/>
-            <a:ext cx="2798064" cy="274320"/>
-          </a:xfrm>
-          <a:prstGeom prst="rect">
-            <a:avLst/>
-          </a:prstGeom>
-          <a:noFill/>
-          <a:ln/>
-        </p:spPr>
-        <p:txBody>
-          <a:bodyPr wrap="square" lIns="0" tIns="0" rIns="0" bIns="0" rtlCol="0" anchor="t"/>
-          <a:lstStyle/>
-          <a:p>
-            <a:pPr algn="ctr" indent="0" marL="0">
-              <a:buNone/>
-            </a:pPr>
-            <a:r>
-              <a:rPr lang="en-US" sz="1200" dirty="0">
+              <a:t>Entrevista en oficina</a:t>
+            </a:r>
+            <a:endParaRPr lang="en-US" sz="1600" dirty="0"/>
+          </a:p>
+          <a:p>
+            <a:pPr indent="0" marL="0">
+              <a:buNone/>
+            </a:pPr>
+            <a:r>
+              <a:rPr lang="en-US" sz="1600" dirty="0">
                 <a:solidFill>
                   <a:srgbClr val="6B3A2A"/>
                 </a:solidFill>
               </a:rPr>
-              <a:t>Entrevista en oficina</a:t>
-            </a:r>
-            <a:endParaRPr lang="en-US" sz="1200" dirty="0"/>
-          </a:p>
-        </p:txBody>
-      </p:sp>
-      <p:sp>
-        <p:nvSpPr>
-          <p:cNvPr id="16" name="IMAGEN_3"/>
-          <p:cNvSpPr/>
-          <p:nvPr/>
-        </p:nvSpPr>
-        <p:spPr>
-          <a:xfrm>
-            <a:off x="5852160" y="3657600"/>
-            <a:ext cx="5788152" cy="2240280"/>
-          </a:xfrm>
-          <a:prstGeom prst="roundRect">
-            <a:avLst>
-              <a:gd name="adj" fmla="val 6122"/>
-            </a:avLst>
-          </a:prstGeom>
-          <a:solidFill>
-            <a:srgbClr val="F0E2CF"/>
-          </a:solidFill>
-          <a:ln w="19050">
-            <a:solidFill>
-              <a:srgbClr val="D9B48F"/>
-            </a:solidFill>
-            <a:prstDash val="dash"/>
-          </a:ln>
-        </p:spPr>
-      </p:sp>
-      <p:pic>
-        <p:nvPicPr>
-          <p:cNvPr id="17" name="Image 2" descr="preencoded.png">    </p:cNvPr>
-          <p:cNvPicPr>
-            <a:picLocks noChangeAspect="1"/>
-          </p:cNvPicPr>
-          <p:nvPr/>
-        </p:nvPicPr>
-        <p:blipFill>
-          <a:blip r:embed="rId3"/>
-          <a:stretch>
-            <a:fillRect/>
-          </a:stretch>
-        </p:blipFill>
-        <p:spPr>
-          <a:xfrm>
-            <a:off x="8426196" y="3909060"/>
-            <a:ext cx="640080" cy="640080"/>
-          </a:xfrm>
-          <a:prstGeom prst="rect">
-            <a:avLst/>
-          </a:prstGeom>
-        </p:spPr>
-      </p:pic>
-      <p:sp>
-        <p:nvSpPr>
-          <p:cNvPr id="18" name="Text 13"/>
-          <p:cNvSpPr txBox="1"/>
-          <p:nvPr/>
-        </p:nvSpPr>
-        <p:spPr>
-          <a:xfrm>
-            <a:off x="6080760" y="4686300"/>
-            <a:ext cx="5330952" cy="1005840"/>
-          </a:xfrm>
-          <a:prstGeom prst="rect">
-            <a:avLst/>
-          </a:prstGeom>
-          <a:noFill/>
-          <a:ln/>
-        </p:spPr>
-        <p:txBody>
-          <a:bodyPr wrap="square" lIns="0" tIns="0" rIns="0" bIns="0" rtlCol="0" anchor="t"/>
-          <a:lstStyle/>
-          <a:p>
-            <a:pPr algn="ctr" indent="0" marL="0">
-              <a:buNone/>
-            </a:pPr>
-            <a:r>
-              <a:rPr lang="en-US" sz="2000" b="1" dirty="0">
-                <a:solidFill>
-                  <a:srgbClr val="6B3A2A"/>
-                </a:solidFill>
-              </a:rPr>
-              <a:t>IMAGEN 3</a:t>
-            </a:r>
-            <a:endParaRPr lang="en-US" sz="1400" dirty="0"/>
-          </a:p>
-          <a:p>
-            <a:pPr algn="ctr" indent="0" marL="0">
-              <a:buNone/>
-            </a:pPr>
-            <a:r>
-              <a:rPr lang="en-US" sz="1400" dirty="0">
-                <a:solidFill>
-                  <a:srgbClr val="6B3A2A"/>
-                </a:solidFill>
-              </a:rPr>
-              <a:t>Captura del focus 1 virtual (foto real)</a:t>
-            </a:r>
-            <a:endParaRPr lang="en-US" sz="1400" dirty="0"/>
-          </a:p>
-        </p:txBody>
-      </p:sp>
-      <p:sp>
-        <p:nvSpPr>
-          <p:cNvPr id="19" name="Text 14"/>
+              <a:t>10 entrevistas en las semanas 1 a 4; videos en YouTube y en el Drive</a:t>
+            </a:r>
+            <a:endParaRPr lang="en-US" sz="1600" dirty="0"/>
+          </a:p>
+        </p:txBody>
+      </p:sp>
+      <p:sp>
+        <p:nvSpPr>
+          <p:cNvPr id="16" name="Text 12"/>
           <p:cNvSpPr txBox="1"/>
           <p:nvPr/>
         </p:nvSpPr>
@@ -8375,36 +8302,9 @@
           <a:chExt cx="0" cy="0"/>
         </a:xfrm>
       </p:grpSpPr>
-      <p:sp>
-        <p:nvSpPr>
-          <p:cNvPr id="2" name="IMAGEN_4"/>
-          <p:cNvSpPr/>
-          <p:nvPr/>
-        </p:nvSpPr>
-        <p:spPr>
-          <a:xfrm>
-            <a:off x="0" y="0"/>
-            <a:ext cx="12191695" cy="6858000"/>
-          </a:xfrm>
-          <a:prstGeom prst="rect">
-            <a:avLst>
-              <a:gd name="adj" fmla="val 2000"/>
-            </a:avLst>
-          </a:prstGeom>
-          <a:solidFill>
-            <a:srgbClr val="5E2C22"/>
-          </a:solidFill>
-          <a:ln w="19050">
-            <a:solidFill>
-              <a:srgbClr val="D9B48F"/>
-            </a:solidFill>
-            <a:prstDash val="dash"/>
-          </a:ln>
-        </p:spPr>
-      </p:sp>
       <p:pic>
         <p:nvPicPr>
-          <p:cNvPr id="3" name="Image 0" descr="preencoded.png">    </p:cNvPr>
+          <p:cNvPr id="2" name="foto_4" descr="preencoded.png">    </p:cNvPr>
           <p:cNvPicPr>
             <a:picLocks noChangeAspect="1"/>
           </p:cNvPicPr>
@@ -8418,14 +8318,41 @@
         </p:blipFill>
         <p:spPr>
           <a:xfrm>
-            <a:off x="9372600" y="2560320"/>
-            <a:ext cx="640080" cy="640080"/>
+            <a:off x="0" y="0"/>
+            <a:ext cx="12191695" cy="6858000"/>
           </a:xfrm>
           <a:prstGeom prst="rect">
             <a:avLst/>
           </a:prstGeom>
         </p:spPr>
       </p:pic>
+      <p:sp>
+        <p:nvSpPr>
+          <p:cNvPr id="3" name="Shape 0"/>
+          <p:cNvSpPr/>
+          <p:nvPr/>
+        </p:nvSpPr>
+        <p:spPr>
+          <a:xfrm>
+            <a:off x="0" y="0"/>
+            <a:ext cx="7132320" cy="6858000"/>
+          </a:xfrm>
+          <a:prstGeom prst="rect">
+            <a:avLst/>
+          </a:prstGeom>
+          <a:solidFill>
+            <a:srgbClr val="4A2018">
+              <a:alpha val="75000"/>
+            </a:srgbClr>
+          </a:solidFill>
+          <a:ln w="12700">
+            <a:solidFill>
+              <a:srgbClr val="4A2018"/>
+            </a:solidFill>
+            <a:prstDash val="solid"/>
+          </a:ln>
+        </p:spPr>
+      </p:sp>
       <p:sp>
         <p:nvSpPr>
           <p:cNvPr id="4" name="Text 1"/>
@@ -8434,8 +8361,8 @@
         </p:nvSpPr>
         <p:spPr>
           <a:xfrm>
-            <a:off x="7452360" y="3337560"/>
-            <a:ext cx="4480560" cy="1005840"/>
+            <a:off x="548640" y="1417320"/>
+            <a:ext cx="10058400" cy="274320"/>
           </a:xfrm>
           <a:prstGeom prst="rect">
             <a:avLst/>
@@ -8447,30 +8374,16 @@
           <a:bodyPr wrap="square" lIns="0" tIns="0" rIns="0" bIns="0" rtlCol="0" anchor="t"/>
           <a:lstStyle/>
           <a:p>
-            <a:pPr algn="ctr" indent="0" marL="0">
-              <a:buNone/>
-            </a:pPr>
-            <a:r>
-              <a:rPr lang="en-US" sz="2000" b="1" dirty="0">
-                <a:solidFill>
-                  <a:srgbClr val="FBF3E8"/>
-                </a:solidFill>
-              </a:rPr>
-              <a:t>IMAGEN 4</a:t>
-            </a:r>
-            <a:endParaRPr lang="en-US" sz="1400" dirty="0"/>
-          </a:p>
-          <a:p>
-            <a:pPr algn="ctr" indent="0" marL="0">
-              <a:buNone/>
-            </a:pPr>
-            <a:r>
-              <a:rPr lang="en-US" sz="1400" dirty="0">
-                <a:solidFill>
-                  <a:srgbClr val="FBF3E8"/>
-                </a:solidFill>
-              </a:rPr>
-              <a:t>Lonchera que vuelve intacta (generada, a sangre completa)</a:t>
+            <a:pPr indent="0" marL="0">
+              <a:buNone/>
+            </a:pPr>
+            <a:r>
+              <a:rPr lang="en-US" sz="1400" b="1" spc="200" kern="0" dirty="0">
+                <a:solidFill>
+                  <a:srgbClr val="E3A33B"/>
+                </a:solidFill>
+              </a:rPr>
+              <a:t>HALLAZGO 1</a:t>
             </a:r>
             <a:endParaRPr lang="en-US" sz="1400" dirty="0"/>
           </a:p>
@@ -8484,8 +8397,8 @@
         </p:nvSpPr>
         <p:spPr>
           <a:xfrm>
-            <a:off x="548640" y="1417320"/>
-            <a:ext cx="10058400" cy="274320"/>
+            <a:off x="548640" y="1783080"/>
+            <a:ext cx="6400800" cy="1508760"/>
           </a:xfrm>
           <a:prstGeom prst="rect">
             <a:avLst/>
@@ -8501,14 +8414,14 @@
               <a:buNone/>
             </a:pPr>
             <a:r>
-              <a:rPr lang="en-US" sz="1400" b="1" spc="200" kern="0" dirty="0">
-                <a:solidFill>
-                  <a:srgbClr val="E3A33B"/>
-                </a:solidFill>
-              </a:rPr>
-              <a:t>HALLAZGO 1</a:t>
-            </a:r>
-            <a:endParaRPr lang="en-US" sz="1400" dirty="0"/>
+              <a:rPr lang="en-US" sz="4400" b="1" dirty="0">
+                <a:solidFill>
+                  <a:srgbClr val="FBF3E8"/>
+                </a:solidFill>
+              </a:rPr>
+              <a:t>Lo saludable vuelve intacto</a:t>
+            </a:r>
+            <a:endParaRPr lang="en-US" sz="4400" dirty="0"/>
           </a:p>
         </p:txBody>
       </p:sp>
@@ -8520,8 +8433,8 @@
         </p:nvSpPr>
         <p:spPr>
           <a:xfrm>
-            <a:off x="548640" y="1783080"/>
-            <a:ext cx="6400800" cy="1508760"/>
+            <a:off x="548640" y="3429000"/>
+            <a:ext cx="6217920" cy="1188720"/>
           </a:xfrm>
           <a:prstGeom prst="rect">
             <a:avLst/>
@@ -8537,56 +8450,20 @@
               <a:buNone/>
             </a:pPr>
             <a:r>
-              <a:rPr lang="en-US" sz="4400" b="1" dirty="0">
+              <a:rPr lang="en-US" sz="2600" dirty="0">
                 <a:solidFill>
                   <a:srgbClr val="FBF3E8"/>
                 </a:solidFill>
               </a:rPr>
-              <a:t>Lo saludable vuelve intacto</a:t>
-            </a:r>
-            <a:endParaRPr lang="en-US" sz="4400" dirty="0"/>
+              <a:t>La barrera no es saber: es el olor, el color y la textura.</a:t>
+            </a:r>
+            <a:endParaRPr lang="en-US" sz="2600" dirty="0"/>
           </a:p>
         </p:txBody>
       </p:sp>
       <p:sp>
         <p:nvSpPr>
           <p:cNvPr id="7" name="Text 4"/>
-          <p:cNvSpPr txBox="1"/>
-          <p:nvPr/>
-        </p:nvSpPr>
-        <p:spPr>
-          <a:xfrm>
-            <a:off x="548640" y="3429000"/>
-            <a:ext cx="6217920" cy="1188720"/>
-          </a:xfrm>
-          <a:prstGeom prst="rect">
-            <a:avLst/>
-          </a:prstGeom>
-          <a:noFill/>
-          <a:ln/>
-        </p:spPr>
-        <p:txBody>
-          <a:bodyPr wrap="square" lIns="0" tIns="0" rIns="0" bIns="0" rtlCol="0" anchor="t"/>
-          <a:lstStyle/>
-          <a:p>
-            <a:pPr indent="0" marL="0">
-              <a:buNone/>
-            </a:pPr>
-            <a:r>
-              <a:rPr lang="en-US" sz="2600" dirty="0">
-                <a:solidFill>
-                  <a:srgbClr val="FBF3E8"/>
-                </a:solidFill>
-              </a:rPr>
-              <a:t>La barrera no es saber: es el olor, el color y la textura.</a:t>
-            </a:r>
-            <a:endParaRPr lang="en-US" sz="2600" dirty="0"/>
-          </a:p>
-        </p:txBody>
-      </p:sp>
-      <p:sp>
-        <p:nvSpPr>
-          <p:cNvPr id="8" name="Text 5"/>
           <p:cNvSpPr txBox="1"/>
           <p:nvPr/>
         </p:nvSpPr>
@@ -10209,36 +10086,9 @@
           </a:p>
         </p:txBody>
       </p:sp>
-      <p:sp>
-        <p:nvSpPr>
-          <p:cNvPr id="7" name="IMAGEN_1"/>
-          <p:cNvSpPr/>
-          <p:nvPr/>
-        </p:nvSpPr>
-        <p:spPr>
-          <a:xfrm>
-            <a:off x="6766560" y="0"/>
-            <a:ext cx="5425135" cy="6858000"/>
-          </a:xfrm>
-          <a:prstGeom prst="rect">
-            <a:avLst>
-              <a:gd name="adj" fmla="val 2528"/>
-            </a:avLst>
-          </a:prstGeom>
-          <a:solidFill>
-            <a:srgbClr val="5E2C22"/>
-          </a:solidFill>
-          <a:ln w="19050">
-            <a:solidFill>
-              <a:srgbClr val="D9B48F"/>
-            </a:solidFill>
-            <a:prstDash val="dash"/>
-          </a:ln>
-        </p:spPr>
-      </p:sp>
       <p:pic>
         <p:nvPicPr>
-          <p:cNvPr id="8" name="Image 0" descr="preencoded.png">    </p:cNvPr>
+          <p:cNvPr id="7" name="foto_1" descr="preencoded.png">    </p:cNvPr>
           <p:cNvPicPr>
             <a:picLocks noChangeAspect="1"/>
           </p:cNvPicPr>
@@ -10252,64 +10102,14 @@
         </p:blipFill>
         <p:spPr>
           <a:xfrm>
-            <a:off x="9159088" y="2560320"/>
-            <a:ext cx="640080" cy="640080"/>
+            <a:off x="6766560" y="0"/>
+            <a:ext cx="5425135" cy="6858000"/>
           </a:xfrm>
           <a:prstGeom prst="rect">
             <a:avLst/>
           </a:prstGeom>
         </p:spPr>
       </p:pic>
-      <p:sp>
-        <p:nvSpPr>
-          <p:cNvPr id="9" name="Text 6"/>
-          <p:cNvSpPr txBox="1"/>
-          <p:nvPr/>
-        </p:nvSpPr>
-        <p:spPr>
-          <a:xfrm>
-            <a:off x="6995160" y="3337560"/>
-            <a:ext cx="4967935" cy="1005840"/>
-          </a:xfrm>
-          <a:prstGeom prst="rect">
-            <a:avLst/>
-          </a:prstGeom>
-          <a:noFill/>
-          <a:ln/>
-        </p:spPr>
-        <p:txBody>
-          <a:bodyPr wrap="square" lIns="0" tIns="0" rIns="0" bIns="0" rtlCol="0" anchor="t"/>
-          <a:lstStyle/>
-          <a:p>
-            <a:pPr algn="ctr" indent="0" marL="0">
-              <a:buNone/>
-            </a:pPr>
-            <a:r>
-              <a:rPr lang="en-US" sz="2000" b="1" dirty="0">
-                <a:solidFill>
-                  <a:srgbClr val="FBF3E8"/>
-                </a:solidFill>
-              </a:rPr>
-              <a:t>IMAGEN 1</a:t>
-            </a:r>
-            <a:endParaRPr lang="en-US" sz="1400" dirty="0"/>
-          </a:p>
-          <a:p>
-            <a:pPr algn="ctr" indent="0" marL="0">
-              <a:buNone/>
-            </a:pPr>
-            <a:r>
-              <a:rPr lang="en-US" sz="1400" dirty="0">
-                <a:solidFill>
-                  <a:srgbClr val="FBF3E8"/>
-                </a:solidFill>
-              </a:rPr>
-              <a:t>Manos armando la lonchera de la mañana (generada)</a:t>
-            </a:r>
-            <a:endParaRPr lang="en-US" sz="1400" dirty="0"/>
-          </a:p>
-        </p:txBody>
-      </p:sp>
       <p:sp>
         <p:nvSpPr>
           <p:cNvPr id="25" name="Slide Number Placeholder 0"/>
@@ -29408,36 +29208,9 @@
           </a:p>
         </p:txBody>
       </p:sp>
-      <p:sp>
-        <p:nvSpPr>
-          <p:cNvPr id="14" name="IMAGEN_2"/>
-          <p:cNvSpPr/>
-          <p:nvPr/>
-        </p:nvSpPr>
-        <p:spPr>
-          <a:xfrm>
-            <a:off x="7498080" y="0"/>
-            <a:ext cx="4693615" cy="6858000"/>
-          </a:xfrm>
-          <a:prstGeom prst="rect">
-            <a:avLst>
-              <a:gd name="adj" fmla="val 2922"/>
-            </a:avLst>
-          </a:prstGeom>
-          <a:solidFill>
-            <a:srgbClr val="F0E2CF"/>
-          </a:solidFill>
-          <a:ln w="19050">
-            <a:solidFill>
-              <a:srgbClr val="D9B48F"/>
-            </a:solidFill>
-            <a:prstDash val="dash"/>
-          </a:ln>
-        </p:spPr>
-      </p:sp>
       <p:pic>
         <p:nvPicPr>
-          <p:cNvPr id="15" name="Image 3" descr="preencoded.png">    </p:cNvPr>
+          <p:cNvPr id="14" name="foto_2" descr="preencoded.png">    </p:cNvPr>
           <p:cNvPicPr>
             <a:picLocks noChangeAspect="1"/>
           </p:cNvPicPr>
@@ -29451,64 +29224,14 @@
         </p:blipFill>
         <p:spPr>
           <a:xfrm>
-            <a:off x="9524848" y="2560320"/>
-            <a:ext cx="640080" cy="640080"/>
+            <a:off x="7498080" y="0"/>
+            <a:ext cx="4693615" cy="6858000"/>
           </a:xfrm>
           <a:prstGeom prst="rect">
             <a:avLst/>
           </a:prstGeom>
         </p:spPr>
       </p:pic>
-      <p:sp>
-        <p:nvSpPr>
-          <p:cNvPr id="16" name="Text 10"/>
-          <p:cNvSpPr txBox="1"/>
-          <p:nvPr/>
-        </p:nvSpPr>
-        <p:spPr>
-          <a:xfrm>
-            <a:off x="7726680" y="3337560"/>
-            <a:ext cx="4236415" cy="1005840"/>
-          </a:xfrm>
-          <a:prstGeom prst="rect">
-            <a:avLst/>
-          </a:prstGeom>
-          <a:noFill/>
-          <a:ln/>
-        </p:spPr>
-        <p:txBody>
-          <a:bodyPr wrap="square" lIns="0" tIns="0" rIns="0" bIns="0" rtlCol="0" anchor="t"/>
-          <a:lstStyle/>
-          <a:p>
-            <a:pPr algn="ctr" indent="0" marL="0">
-              <a:buNone/>
-            </a:pPr>
-            <a:r>
-              <a:rPr lang="en-US" sz="2000" b="1" dirty="0">
-                <a:solidFill>
-                  <a:srgbClr val="6B3A2A"/>
-                </a:solidFill>
-              </a:rPr>
-              <a:t>IMAGEN 2</a:t>
-            </a:r>
-            <a:endParaRPr lang="en-US" sz="1400" dirty="0"/>
-          </a:p>
-          <a:p>
-            <a:pPr algn="ctr" indent="0" marL="0">
-              <a:buNone/>
-            </a:pPr>
-            <a:r>
-              <a:rPr lang="en-US" sz="1400" dirty="0">
-                <a:solidFill>
-                  <a:srgbClr val="6B3A2A"/>
-                </a:solidFill>
-              </a:rPr>
-              <a:t>Lonchera kraft con el mini brownie (foto real o generada)</a:t>
-            </a:r>
-            <a:endParaRPr lang="en-US" sz="1400" dirty="0"/>
-          </a:p>
-        </p:txBody>
-      </p:sp>
       <p:sp>
         <p:nvSpPr>
           <p:cNvPr id="25" name="Slide Number Placeholder 0"/>

</xml_diff>